<commit_message>
Update Week 37 Tuesday algorithm slides
Refreshes the Tuesday Week 37 PowerPoint on algorithms and basic programming with updated presentation content.
</commit_message>
<xml_diff>
--- a/ppt/Uge37_tirsdag_Algoritmer - Grundlæggende Programmering.pptx
+++ b/ppt/Uge37_tirsdag_Algoritmer - Grundlæggende Programmering.pptx
@@ -3344,8 +3344,8 @@
         </p:nvSpPr>
         <p:spPr>
           <a:xfrm>
-            <a:off x="2857500" y="512763"/>
-            <a:ext cx="3429000" cy="2566987"/>
+            <a:off x="2290763" y="512763"/>
+            <a:ext cx="4562475" cy="2566987"/>
           </a:xfrm>
           <a:prstGeom prst="rect">
             <a:avLst/>
@@ -3820,8 +3820,8 @@
         </p:nvSpPr>
         <p:spPr>
           <a:xfrm>
-            <a:off x="2857500" y="512763"/>
-            <a:ext cx="3429000" cy="2566987"/>
+            <a:off x="2290763" y="512763"/>
+            <a:ext cx="4562475" cy="2566987"/>
           </a:xfrm>
           <a:prstGeom prst="rect">
             <a:avLst/>
@@ -16051,7 +16051,7 @@
               <a:defRPr/>
             </a:pPr>
             <a:r>
-              <a:rPr lang="zh-CN" sz="3000" b="1" i="0" u="none" strike="noStrike">
+              <a:rPr lang="zh-CN" sz="3000" b="1" i="0" u="none" strike="noStrike" dirty="0">
                 <a:solidFill>
                   <a:srgbClr val="000000"/>
                 </a:solidFill>
@@ -16060,9 +16060,9 @@
                 <a:cs typeface="Poppins"/>
                 <a:sym typeface="Poppins"/>
               </a:rPr>
-              <a:t>Hvorfor Scratch?</a:t>
-            </a:r>
-            <a:endParaRPr lang="en-US" sz="3000" b="1" i="0" u="none" strike="noStrike">
+              <a:t>Scratch?</a:t>
+            </a:r>
+            <a:endParaRPr lang="en-US" sz="3000" b="1" i="0" u="none" strike="noStrike" dirty="0">
               <a:solidFill>
                 <a:srgbClr val="000000"/>
               </a:solidFill>
@@ -16074,37 +16074,6 @@
           </a:p>
         </p:txBody>
       </p:sp>
-      <p:pic>
-        <p:nvPicPr>
-          <p:cNvPr id="118" name="Picture 10"/>
-          <p:cNvPicPr>
-            <a:picLocks noChangeAspect="1"/>
-          </p:cNvPicPr>
-          <p:nvPr/>
-        </p:nvPicPr>
-        <p:blipFill>
-          <a:blip r:embed="rId4"/>
-          <a:srcRect/>
-          <a:stretch>
-            <a:fillRect/>
-          </a:stretch>
-        </p:blipFill>
-        <p:spPr>
-          <a:xfrm>
-            <a:off x="508000" y="812800"/>
-            <a:ext cx="368300" cy="317500"/>
-          </a:xfrm>
-          <a:prstGeom prst="rect">
-            <a:avLst/>
-          </a:prstGeom>
-          <a:noFill/>
-          <a:ln w="25400" cap="flat" cmpd="sng">
-            <a:noFill/>
-            <a:prstDash val="solid"/>
-            <a:round/>
-          </a:ln>
-        </p:spPr>
-      </p:pic>
       <p:sp>
         <p:nvSpPr>
           <p:cNvPr id="119" name="AutoShape 11"/>
@@ -16265,37 +16234,6 @@
       </p:sp>
       <p:sp>
         <p:nvSpPr>
-          <p:cNvPr id="123" name="Rounded Rectangle 122"/>
-          <p:cNvSpPr/>
-          <p:nvPr/>
-        </p:nvSpPr>
-        <p:spPr>
-          <a:xfrm>
-            <a:off x="482600" y="1574800"/>
-            <a:ext cx="4318000" cy="787400"/>
-          </a:xfrm>
-          <a:prstGeom prst="roundRect">
-            <a:avLst>
-              <a:gd name="adj" fmla="val 11000"/>
-            </a:avLst>
-          </a:prstGeom>
-          <a:solidFill>
-            <a:srgbClr val="FFAB19"/>
-          </a:solidFill>
-          <a:ln>
-            <a:noFill/>
-          </a:ln>
-        </p:spPr>
-        <p:txBody>
-          <a:bodyPr/>
-          <a:lstStyle/>
-          <a:p>
-            <a:endParaRPr/>
-          </a:p>
-        </p:txBody>
-      </p:sp>
-      <p:sp>
-        <p:nvSpPr>
           <p:cNvPr id="124" name="Rounded Rectangle 123"/>
           <p:cNvSpPr/>
           <p:nvPr/>
@@ -16358,37 +16296,6 @@
       </p:sp>
       <p:sp>
         <p:nvSpPr>
-          <p:cNvPr id="126" name="Rounded Rectangle 125"/>
-          <p:cNvSpPr/>
-          <p:nvPr/>
-        </p:nvSpPr>
-        <p:spPr>
-          <a:xfrm>
-            <a:off x="660400" y="2362200"/>
-            <a:ext cx="609600" cy="101600"/>
-          </a:xfrm>
-          <a:prstGeom prst="roundRect">
-            <a:avLst>
-              <a:gd name="adj" fmla="val 30000"/>
-            </a:avLst>
-          </a:prstGeom>
-          <a:solidFill>
-            <a:srgbClr val="FFAB19"/>
-          </a:solidFill>
-          <a:ln>
-            <a:noFill/>
-          </a:ln>
-        </p:spPr>
-        <p:txBody>
-          <a:bodyPr/>
-          <a:lstStyle/>
-          <a:p>
-            <a:endParaRPr/>
-          </a:p>
-        </p:txBody>
-      </p:sp>
-      <p:sp>
-        <p:nvSpPr>
           <p:cNvPr id="127" name="Rounded Rectangle 126"/>
           <p:cNvSpPr/>
           <p:nvPr/>
@@ -16511,14 +16418,14 @@
       </p:sp>
       <p:sp>
         <p:nvSpPr>
-          <p:cNvPr id="131" name="Rectangle 130"/>
+          <p:cNvPr id="132" name="Rectangle 131"/>
           <p:cNvSpPr/>
           <p:nvPr/>
         </p:nvSpPr>
         <p:spPr>
           <a:xfrm>
-            <a:off x="914400" y="1219200"/>
-            <a:ext cx="5461000" cy="254000"/>
+            <a:off x="660400" y="1714500"/>
+            <a:ext cx="3962400" cy="254000"/>
           </a:xfrm>
           <a:prstGeom prst="rect">
             <a:avLst/>
@@ -16533,43 +16440,6 @@
           <a:lstStyle/>
           <a:p>
             <a:r>
-              <a:rPr lang="zh-CN" sz="1200">
-                <a:solidFill>
-                  <a:srgbClr val="6B6B76"/>
-                </a:solidFill>
-                <a:latin typeface="Geist"/>
-                <a:ea typeface="Geist"/>
-              </a:rPr>
-              <a:t>Blokke først — syntaks bagefter.</a:t>
-            </a:r>
-            <a:endParaRPr/>
-          </a:p>
-        </p:txBody>
-      </p:sp>
-      <p:sp>
-        <p:nvSpPr>
-          <p:cNvPr id="132" name="Rectangle 131"/>
-          <p:cNvSpPr/>
-          <p:nvPr/>
-        </p:nvSpPr>
-        <p:spPr>
-          <a:xfrm>
-            <a:off x="660400" y="1714500"/>
-            <a:ext cx="3962400" cy="254000"/>
-          </a:xfrm>
-          <a:prstGeom prst="rect">
-            <a:avLst/>
-          </a:prstGeom>
-          <a:noFill/>
-          <a:ln>
-            <a:noFill/>
-          </a:ln>
-        </p:spPr>
-        <p:txBody>
-          <a:bodyPr/>
-          <a:lstStyle/>
-          <a:p>
-            <a:r>
               <a:rPr lang="zh-CN" sz="1500" b="1">
                 <a:solidFill>
                   <a:srgbClr val="FFFFFF"/>
@@ -16579,43 +16449,6 @@
               </a:rPr>
               <a:t>Blokke, ikke syntaks</a:t>
             </a:r>
-          </a:p>
-        </p:txBody>
-      </p:sp>
-      <p:sp>
-        <p:nvSpPr>
-          <p:cNvPr id="133" name="Rectangle 132"/>
-          <p:cNvSpPr/>
-          <p:nvPr/>
-        </p:nvSpPr>
-        <p:spPr>
-          <a:xfrm>
-            <a:off x="660400" y="1993900"/>
-            <a:ext cx="3962400" cy="203200"/>
-          </a:xfrm>
-          <a:prstGeom prst="rect">
-            <a:avLst/>
-          </a:prstGeom>
-          <a:noFill/>
-          <a:ln>
-            <a:noFill/>
-          </a:ln>
-        </p:spPr>
-        <p:txBody>
-          <a:bodyPr/>
-          <a:lstStyle/>
-          <a:p>
-            <a:r>
-              <a:rPr lang="zh-CN" sz="1100">
-                <a:solidFill>
-                  <a:srgbClr val="FFE9BF"/>
-                </a:solidFill>
-                <a:latin typeface="Geist"/>
-                <a:ea typeface="Geist"/>
-              </a:rPr>
-              <a:t>De passer kun sammen, hvis logikken gør.</a:t>
-            </a:r>
-            <a:endParaRPr/>
           </a:p>
         </p:txBody>
       </p:sp>
@@ -19181,25 +19014,73 @@
                 <a:cs typeface="Geist"/>
                 <a:sym typeface="Geist"/>
               </a:rPr>
+              <a:t> -</a:t>
+            </a:r>
+            <a:r>
+              <a:rPr lang="en-US" sz="1800" dirty="0">
+                <a:latin typeface="Geist"/>
+                <a:ea typeface="Geist"/>
+                <a:cs typeface="Geist"/>
+                <a:sym typeface="Geist"/>
+              </a:rPr>
+              <a:t>15 </a:t>
+            </a:r>
+            <a:r>
+              <a:rPr lang="en-US" sz="1800" dirty="0" err="1">
+                <a:latin typeface="Geist"/>
+                <a:ea typeface="Geist"/>
+                <a:cs typeface="Geist"/>
+                <a:sym typeface="Geist"/>
+              </a:rPr>
+              <a:t>minutter</a:t>
+            </a:r>
+            <a:r>
+              <a:rPr lang="en-US" sz="1700" b="0" i="0" u="none" strike="noStrike" dirty="0">
+                <a:solidFill>
+                  <a:srgbClr val="000000"/>
+                </a:solidFill>
+                <a:latin typeface="Geist"/>
+                <a:ea typeface="Geist"/>
+                <a:cs typeface="Geist"/>
+                <a:sym typeface="Geist"/>
+              </a:rPr>
+              <a:t>) </a:t>
+            </a:r>
+            <a:r>
+              <a:rPr lang="en-US" sz="1700" b="0" i="0" u="none" strike="noStrike" dirty="0" err="1">
+                <a:solidFill>
+                  <a:srgbClr val="000000"/>
+                </a:solidFill>
+                <a:latin typeface="Geist"/>
+                <a:ea typeface="Geist"/>
+                <a:cs typeface="Geist"/>
+                <a:sym typeface="Geist"/>
+              </a:rPr>
+              <a:t>og</a:t>
+            </a:r>
+            <a:r>
+              <a:rPr lang="en-US" sz="1700" b="0" i="0" u="none" strike="noStrike" dirty="0">
+                <a:solidFill>
+                  <a:srgbClr val="000000"/>
+                </a:solidFill>
+                <a:latin typeface="Geist"/>
+                <a:ea typeface="Geist"/>
+                <a:cs typeface="Geist"/>
+                <a:sym typeface="Geist"/>
+              </a:rPr>
               <a:t> </a:t>
             </a:r>
             <a:r>
-              <a:rPr lang="en-US" sz="1800" b="1" dirty="0">
-                <a:latin typeface="Geist"/>
-                <a:ea typeface="Geist"/>
-                <a:cs typeface="Geist"/>
-                <a:sym typeface="Geist"/>
-              </a:rPr>
-              <a:t>15 </a:t>
-            </a:r>
-            <a:r>
-              <a:rPr lang="en-US" sz="1800" b="1" dirty="0" err="1">
-                <a:latin typeface="Geist"/>
-                <a:ea typeface="Geist"/>
-                <a:cs typeface="Geist"/>
-                <a:sym typeface="Geist"/>
-              </a:rPr>
-              <a:t>minutter</a:t>
+              <a:rPr lang="en-US" sz="1700" b="0" i="0" u="none" strike="noStrike" dirty="0" err="1">
+                <a:solidFill>
+                  <a:srgbClr val="000000"/>
+                </a:solidFill>
+                <a:latin typeface="Geist"/>
+                <a:ea typeface="Geist"/>
+                <a:cs typeface="Geist"/>
+                <a:sym typeface="Geist"/>
+              </a:rPr>
+              <a:t>analyse</a:t>
             </a:r>
             <a:r>
               <a:rPr lang="en-US" sz="1700" b="0" i="0" u="none" strike="noStrike" dirty="0">
@@ -19211,7 +19092,7 @@
                 <a:cs typeface="Geist"/>
                 <a:sym typeface="Geist"/>
               </a:rPr>
-              <a:t>) </a:t>
+              <a:t>  scratch </a:t>
             </a:r>
             <a:r>
               <a:rPr lang="en-US" sz="1700" b="0" i="0" u="none" strike="noStrike" dirty="0" err="1">
@@ -19223,7 +19104,7 @@
                 <a:cs typeface="Geist"/>
                 <a:sym typeface="Geist"/>
               </a:rPr>
-              <a:t>og</a:t>
+              <a:t>kode</a:t>
             </a:r>
             <a:r>
               <a:rPr lang="en-US" sz="1700" b="0" i="0" u="none" strike="noStrike" dirty="0">
@@ -19235,55 +19116,7 @@
                 <a:cs typeface="Geist"/>
                 <a:sym typeface="Geist"/>
               </a:rPr>
-              <a:t> </a:t>
-            </a:r>
-            <a:r>
-              <a:rPr lang="en-US" sz="1700" b="0" i="0" u="none" strike="noStrike" dirty="0" err="1">
-                <a:solidFill>
-                  <a:srgbClr val="000000"/>
-                </a:solidFill>
-                <a:latin typeface="Geist"/>
-                <a:ea typeface="Geist"/>
-                <a:cs typeface="Geist"/>
-                <a:sym typeface="Geist"/>
-              </a:rPr>
-              <a:t>analyse</a:t>
-            </a:r>
-            <a:r>
-              <a:rPr lang="en-US" sz="1700" b="0" i="0" u="none" strike="noStrike" dirty="0">
-                <a:solidFill>
-                  <a:srgbClr val="000000"/>
-                </a:solidFill>
-                <a:latin typeface="Geist"/>
-                <a:ea typeface="Geist"/>
-                <a:cs typeface="Geist"/>
-                <a:sym typeface="Geist"/>
-              </a:rPr>
-              <a:t> 2 scratch </a:t>
-            </a:r>
-            <a:r>
-              <a:rPr lang="en-US" sz="1700" b="0" i="0" u="none" strike="noStrike" dirty="0" err="1">
-                <a:solidFill>
-                  <a:srgbClr val="000000"/>
-                </a:solidFill>
-                <a:latin typeface="Geist"/>
-                <a:ea typeface="Geist"/>
-                <a:cs typeface="Geist"/>
-                <a:sym typeface="Geist"/>
-              </a:rPr>
-              <a:t>kode</a:t>
-            </a:r>
-            <a:r>
-              <a:rPr lang="en-US" sz="1700" b="0" i="0" u="none" strike="noStrike" dirty="0">
-                <a:solidFill>
-                  <a:srgbClr val="000000"/>
-                </a:solidFill>
-                <a:latin typeface="Geist"/>
-                <a:ea typeface="Geist"/>
-                <a:cs typeface="Geist"/>
-                <a:sym typeface="Geist"/>
-              </a:rPr>
-              <a:t> sample</a:t>
+              <a:t> links</a:t>
             </a:r>
             <a:endParaRPr dirty="0"/>
           </a:p>
@@ -19763,7 +19596,7 @@
               <a:defRPr/>
             </a:pPr>
             <a:r>
-              <a:rPr lang="en-US" sz="1500" b="1" i="0" u="none" strike="noStrike">
+              <a:rPr lang="en-US" sz="1500" b="1" i="0" u="none" strike="noStrike" dirty="0" err="1">
                 <a:solidFill>
                   <a:srgbClr val="FFFFFF"/>
                 </a:solidFill>
@@ -19775,7 +19608,7 @@
               <a:t>Algoritmer</a:t>
             </a:r>
             <a:r>
-              <a:rPr lang="en-US" sz="1300" b="0" i="0" u="none" strike="noStrike">
+              <a:rPr lang="en-US" sz="1300" b="0" i="0" u="none" strike="noStrike" dirty="0" err="1">
                 <a:solidFill>
                   <a:srgbClr val="FFFFFF"/>
                 </a:solidFill>
@@ -21528,30 +21361,498 @@
               <a:defRPr/>
             </a:pPr>
             <a:r>
-              <a:rPr lang="en-US" sz="2000" b="1" i="0" u="none" strike="noStrike">
-                <a:solidFill>
-                  <a:srgbClr val="000000"/>
-                </a:solidFill>
-                <a:latin typeface="Geist"/>
-                <a:ea typeface="Geist"/>
-                <a:cs typeface="Geist"/>
-                <a:sym typeface="Geist"/>
-              </a:rPr>
-              <a:t>Kursus Mål:</a:t>
-            </a:r>
-            <a:r>
-              <a:rPr lang="en-US" sz="1800" b="0" i="0" u="none" strike="noStrike">
-                <a:solidFill>
-                  <a:srgbClr val="000000"/>
-                </a:solidFill>
-                <a:latin typeface="Geist"/>
-                <a:ea typeface="Geist"/>
-                <a:cs typeface="Geist"/>
-                <a:sym typeface="Geist"/>
-              </a:rPr>
-              <a:t>Forstå definitionen af en algoritme, dens rolle i datalogi og principperne bag konstruktion af en logisk, trinvis løsning til en given opgave.</a:t>
-            </a:r>
-            <a:endParaRPr lang="en-US" sz="1100"/>
+              <a:rPr lang="en-US" sz="2000" b="1" i="0" u="none" strike="noStrike" dirty="0" err="1">
+                <a:solidFill>
+                  <a:srgbClr val="000000"/>
+                </a:solidFill>
+                <a:latin typeface="Geist"/>
+                <a:ea typeface="Geist"/>
+                <a:cs typeface="Geist"/>
+                <a:sym typeface="Geist"/>
+              </a:rPr>
+              <a:t>Kursus</a:t>
+            </a:r>
+            <a:r>
+              <a:rPr lang="en-US" sz="2000" b="1" i="0" u="none" strike="noStrike" dirty="0">
+                <a:solidFill>
+                  <a:srgbClr val="000000"/>
+                </a:solidFill>
+                <a:latin typeface="Geist"/>
+                <a:ea typeface="Geist"/>
+                <a:cs typeface="Geist"/>
+                <a:sym typeface="Geist"/>
+              </a:rPr>
+              <a:t> </a:t>
+            </a:r>
+            <a:r>
+              <a:rPr lang="en-US" sz="2000" b="1" i="0" u="none" strike="noStrike" dirty="0" err="1">
+                <a:solidFill>
+                  <a:srgbClr val="000000"/>
+                </a:solidFill>
+                <a:latin typeface="Geist"/>
+                <a:ea typeface="Geist"/>
+                <a:cs typeface="Geist"/>
+                <a:sym typeface="Geist"/>
+              </a:rPr>
+              <a:t>Mål:</a:t>
+            </a:r>
+            <a:r>
+              <a:rPr lang="en-US" sz="1800" b="0" i="0" u="none" strike="noStrike" dirty="0" err="1">
+                <a:solidFill>
+                  <a:srgbClr val="000000"/>
+                </a:solidFill>
+                <a:latin typeface="Geist"/>
+                <a:ea typeface="Geist"/>
+                <a:cs typeface="Geist"/>
+                <a:sym typeface="Geist"/>
+              </a:rPr>
+              <a:t>Forstå</a:t>
+            </a:r>
+            <a:r>
+              <a:rPr lang="en-US" sz="1800" b="0" i="0" u="none" strike="noStrike" dirty="0">
+                <a:solidFill>
+                  <a:srgbClr val="000000"/>
+                </a:solidFill>
+                <a:latin typeface="Geist"/>
+                <a:ea typeface="Geist"/>
+                <a:cs typeface="Geist"/>
+                <a:sym typeface="Geist"/>
+              </a:rPr>
+              <a:t> </a:t>
+            </a:r>
+            <a:r>
+              <a:rPr lang="en-US" sz="1800" b="0" i="0" u="none" strike="noStrike" dirty="0" err="1">
+                <a:solidFill>
+                  <a:srgbClr val="000000"/>
+                </a:solidFill>
+                <a:latin typeface="Geist"/>
+                <a:ea typeface="Geist"/>
+                <a:cs typeface="Geist"/>
+                <a:sym typeface="Geist"/>
+              </a:rPr>
+              <a:t>definitionen</a:t>
+            </a:r>
+            <a:r>
+              <a:rPr lang="en-US" sz="1800" b="0" i="0" u="none" strike="noStrike" dirty="0">
+                <a:solidFill>
+                  <a:srgbClr val="000000"/>
+                </a:solidFill>
+                <a:latin typeface="Geist"/>
+                <a:ea typeface="Geist"/>
+                <a:cs typeface="Geist"/>
+                <a:sym typeface="Geist"/>
+              </a:rPr>
+              <a:t> </a:t>
+            </a:r>
+            <a:r>
+              <a:rPr lang="en-US" sz="1800" b="0" i="0" u="none" strike="noStrike" dirty="0" err="1">
+                <a:solidFill>
+                  <a:srgbClr val="000000"/>
+                </a:solidFill>
+                <a:latin typeface="Geist"/>
+                <a:ea typeface="Geist"/>
+                <a:cs typeface="Geist"/>
+                <a:sym typeface="Geist"/>
+              </a:rPr>
+              <a:t>af</a:t>
+            </a:r>
+            <a:r>
+              <a:rPr lang="en-US" sz="1800" b="0" i="0" u="none" strike="noStrike" dirty="0">
+                <a:solidFill>
+                  <a:srgbClr val="000000"/>
+                </a:solidFill>
+                <a:latin typeface="Geist"/>
+                <a:ea typeface="Geist"/>
+                <a:cs typeface="Geist"/>
+                <a:sym typeface="Geist"/>
+              </a:rPr>
+              <a:t> </a:t>
+            </a:r>
+            <a:r>
+              <a:rPr lang="en-US" sz="1800" b="0" i="0" u="none" strike="noStrike" dirty="0" err="1">
+                <a:solidFill>
+                  <a:srgbClr val="000000"/>
+                </a:solidFill>
+                <a:latin typeface="Geist"/>
+                <a:ea typeface="Geist"/>
+                <a:cs typeface="Geist"/>
+                <a:sym typeface="Geist"/>
+              </a:rPr>
+              <a:t>en</a:t>
+            </a:r>
+            <a:r>
+              <a:rPr lang="en-US" sz="1800" b="0" i="0" u="none" strike="noStrike" dirty="0">
+                <a:solidFill>
+                  <a:srgbClr val="000000"/>
+                </a:solidFill>
+                <a:latin typeface="Geist"/>
+                <a:ea typeface="Geist"/>
+                <a:cs typeface="Geist"/>
+                <a:sym typeface="Geist"/>
+              </a:rPr>
+              <a:t> </a:t>
+            </a:r>
+            <a:r>
+              <a:rPr lang="en-US" sz="1800" b="0" i="0" u="none" strike="noStrike" dirty="0" err="1">
+                <a:solidFill>
+                  <a:srgbClr val="000000"/>
+                </a:solidFill>
+                <a:latin typeface="Geist"/>
+                <a:ea typeface="Geist"/>
+                <a:cs typeface="Geist"/>
+                <a:sym typeface="Geist"/>
+              </a:rPr>
+              <a:t>algoritme</a:t>
+            </a:r>
+            <a:r>
+              <a:rPr lang="en-US" sz="1800" b="0" i="0" u="none" strike="noStrike" dirty="0">
+                <a:solidFill>
+                  <a:srgbClr val="000000"/>
+                </a:solidFill>
+                <a:latin typeface="Geist"/>
+                <a:ea typeface="Geist"/>
+                <a:cs typeface="Geist"/>
+                <a:sym typeface="Geist"/>
+              </a:rPr>
+              <a:t>, dens </a:t>
+            </a:r>
+            <a:r>
+              <a:rPr lang="en-US" sz="1800" b="0" i="0" u="none" strike="noStrike" dirty="0" err="1">
+                <a:solidFill>
+                  <a:srgbClr val="000000"/>
+                </a:solidFill>
+                <a:latin typeface="Geist"/>
+                <a:ea typeface="Geist"/>
+                <a:cs typeface="Geist"/>
+                <a:sym typeface="Geist"/>
+              </a:rPr>
+              <a:t>rolle</a:t>
+            </a:r>
+            <a:r>
+              <a:rPr lang="en-US" sz="1800" b="0" i="0" u="none" strike="noStrike" dirty="0">
+                <a:solidFill>
+                  <a:srgbClr val="000000"/>
+                </a:solidFill>
+                <a:latin typeface="Geist"/>
+                <a:ea typeface="Geist"/>
+                <a:cs typeface="Geist"/>
+                <a:sym typeface="Geist"/>
+              </a:rPr>
+              <a:t> </a:t>
+            </a:r>
+            <a:r>
+              <a:rPr lang="en-US" sz="1800" b="0" i="0" u="none" strike="noStrike" dirty="0" err="1">
+                <a:solidFill>
+                  <a:srgbClr val="000000"/>
+                </a:solidFill>
+                <a:latin typeface="Geist"/>
+                <a:ea typeface="Geist"/>
+                <a:cs typeface="Geist"/>
+                <a:sym typeface="Geist"/>
+              </a:rPr>
+              <a:t>i</a:t>
+            </a:r>
+            <a:r>
+              <a:rPr lang="en-US" sz="1800" b="0" i="0" u="none" strike="noStrike" dirty="0">
+                <a:solidFill>
+                  <a:srgbClr val="000000"/>
+                </a:solidFill>
+                <a:latin typeface="Geist"/>
+                <a:ea typeface="Geist"/>
+                <a:cs typeface="Geist"/>
+                <a:sym typeface="Geist"/>
+              </a:rPr>
+              <a:t> </a:t>
+            </a:r>
+            <a:r>
+              <a:rPr lang="en-US" sz="1800" b="0" i="0" u="none" strike="noStrike" dirty="0" err="1">
+                <a:solidFill>
+                  <a:srgbClr val="000000"/>
+                </a:solidFill>
+                <a:latin typeface="Geist"/>
+                <a:ea typeface="Geist"/>
+                <a:cs typeface="Geist"/>
+                <a:sym typeface="Geist"/>
+              </a:rPr>
+              <a:t>datalogi</a:t>
+            </a:r>
+            <a:r>
+              <a:rPr lang="en-US" sz="1800" b="0" i="0" u="none" strike="noStrike" dirty="0">
+                <a:solidFill>
+                  <a:srgbClr val="000000"/>
+                </a:solidFill>
+                <a:latin typeface="Geist"/>
+                <a:ea typeface="Geist"/>
+                <a:cs typeface="Geist"/>
+                <a:sym typeface="Geist"/>
+              </a:rPr>
+              <a:t> </a:t>
+            </a:r>
+            <a:r>
+              <a:rPr lang="en-US" sz="1800" b="0" i="0" u="none" strike="noStrike" dirty="0" err="1">
+                <a:solidFill>
+                  <a:srgbClr val="000000"/>
+                </a:solidFill>
+                <a:latin typeface="Geist"/>
+                <a:ea typeface="Geist"/>
+                <a:cs typeface="Geist"/>
+                <a:sym typeface="Geist"/>
+              </a:rPr>
+              <a:t>og</a:t>
+            </a:r>
+            <a:r>
+              <a:rPr lang="en-US" sz="1800" b="0" i="0" u="none" strike="noStrike" dirty="0">
+                <a:solidFill>
+                  <a:srgbClr val="000000"/>
+                </a:solidFill>
+                <a:latin typeface="Geist"/>
+                <a:ea typeface="Geist"/>
+                <a:cs typeface="Geist"/>
+                <a:sym typeface="Geist"/>
+              </a:rPr>
+              <a:t> </a:t>
+            </a:r>
+            <a:r>
+              <a:rPr lang="en-US" sz="1800" b="0" i="0" u="none" strike="noStrike" dirty="0" err="1">
+                <a:solidFill>
+                  <a:srgbClr val="000000"/>
+                </a:solidFill>
+                <a:latin typeface="Geist"/>
+                <a:ea typeface="Geist"/>
+                <a:cs typeface="Geist"/>
+                <a:sym typeface="Geist"/>
+              </a:rPr>
+              <a:t>principperne</a:t>
+            </a:r>
+            <a:r>
+              <a:rPr lang="en-US" sz="1800" b="0" i="0" u="none" strike="noStrike" dirty="0">
+                <a:solidFill>
+                  <a:srgbClr val="000000"/>
+                </a:solidFill>
+                <a:latin typeface="Geist"/>
+                <a:ea typeface="Geist"/>
+                <a:cs typeface="Geist"/>
+                <a:sym typeface="Geist"/>
+              </a:rPr>
+              <a:t> bag </a:t>
+            </a:r>
+            <a:r>
+              <a:rPr lang="en-US" sz="1800" b="0" i="0" u="none" strike="noStrike" dirty="0" err="1">
+                <a:solidFill>
+                  <a:srgbClr val="000000"/>
+                </a:solidFill>
+                <a:latin typeface="Geist"/>
+                <a:ea typeface="Geist"/>
+                <a:cs typeface="Geist"/>
+                <a:sym typeface="Geist"/>
+              </a:rPr>
+              <a:t>konstruktion</a:t>
+            </a:r>
+            <a:r>
+              <a:rPr lang="en-US" sz="1800" b="0" i="0" u="none" strike="noStrike" dirty="0">
+                <a:solidFill>
+                  <a:srgbClr val="000000"/>
+                </a:solidFill>
+                <a:latin typeface="Geist"/>
+                <a:ea typeface="Geist"/>
+                <a:cs typeface="Geist"/>
+                <a:sym typeface="Geist"/>
+              </a:rPr>
+              <a:t> </a:t>
+            </a:r>
+            <a:r>
+              <a:rPr lang="en-US" sz="1800" b="0" i="0" u="none" strike="noStrike" dirty="0" err="1">
+                <a:solidFill>
+                  <a:srgbClr val="000000"/>
+                </a:solidFill>
+                <a:latin typeface="Geist"/>
+                <a:ea typeface="Geist"/>
+                <a:cs typeface="Geist"/>
+                <a:sym typeface="Geist"/>
+              </a:rPr>
+              <a:t>af</a:t>
+            </a:r>
+            <a:r>
+              <a:rPr lang="en-US" sz="1800" b="0" i="0" u="none" strike="noStrike" dirty="0">
+                <a:solidFill>
+                  <a:srgbClr val="000000"/>
+                </a:solidFill>
+                <a:latin typeface="Geist"/>
+                <a:ea typeface="Geist"/>
+                <a:cs typeface="Geist"/>
+                <a:sym typeface="Geist"/>
+              </a:rPr>
+              <a:t> </a:t>
+            </a:r>
+            <a:r>
+              <a:rPr lang="en-US" sz="1800" b="0" i="0" u="none" strike="noStrike" dirty="0" err="1">
+                <a:solidFill>
+                  <a:srgbClr val="000000"/>
+                </a:solidFill>
+                <a:latin typeface="Geist"/>
+                <a:ea typeface="Geist"/>
+                <a:cs typeface="Geist"/>
+                <a:sym typeface="Geist"/>
+              </a:rPr>
+              <a:t>en</a:t>
+            </a:r>
+            <a:r>
+              <a:rPr lang="en-US" sz="1800" b="0" i="0" u="none" strike="noStrike" dirty="0">
+                <a:solidFill>
+                  <a:srgbClr val="000000"/>
+                </a:solidFill>
+                <a:latin typeface="Geist"/>
+                <a:ea typeface="Geist"/>
+                <a:cs typeface="Geist"/>
+                <a:sym typeface="Geist"/>
+              </a:rPr>
+              <a:t> </a:t>
+            </a:r>
+            <a:r>
+              <a:rPr lang="en-US" sz="1800" b="0" i="0" u="none" strike="noStrike" dirty="0" err="1">
+                <a:solidFill>
+                  <a:srgbClr val="000000"/>
+                </a:solidFill>
+                <a:latin typeface="Geist"/>
+                <a:ea typeface="Geist"/>
+                <a:cs typeface="Geist"/>
+                <a:sym typeface="Geist"/>
+              </a:rPr>
+              <a:t>logisk</a:t>
+            </a:r>
+            <a:r>
+              <a:rPr lang="en-US" sz="1800" b="0" i="0" u="none" strike="noStrike" dirty="0">
+                <a:solidFill>
+                  <a:srgbClr val="000000"/>
+                </a:solidFill>
+                <a:latin typeface="Geist"/>
+                <a:ea typeface="Geist"/>
+                <a:cs typeface="Geist"/>
+                <a:sym typeface="Geist"/>
+              </a:rPr>
+              <a:t>, </a:t>
+            </a:r>
+            <a:r>
+              <a:rPr lang="en-US" sz="1800" b="0" i="0" u="none" strike="noStrike" dirty="0" err="1">
+                <a:solidFill>
+                  <a:srgbClr val="000000"/>
+                </a:solidFill>
+                <a:latin typeface="Geist"/>
+                <a:ea typeface="Geist"/>
+                <a:cs typeface="Geist"/>
+                <a:sym typeface="Geist"/>
+              </a:rPr>
+              <a:t>trinvis</a:t>
+            </a:r>
+            <a:r>
+              <a:rPr lang="en-US" sz="1800" b="0" i="0" u="none" strike="noStrike" dirty="0">
+                <a:solidFill>
+                  <a:srgbClr val="000000"/>
+                </a:solidFill>
+                <a:latin typeface="Geist"/>
+                <a:ea typeface="Geist"/>
+                <a:cs typeface="Geist"/>
+                <a:sym typeface="Geist"/>
+              </a:rPr>
+              <a:t> </a:t>
+            </a:r>
+            <a:r>
+              <a:rPr lang="en-US" sz="1800" b="0" i="0" u="none" strike="noStrike" dirty="0" err="1">
+                <a:solidFill>
+                  <a:srgbClr val="000000"/>
+                </a:solidFill>
+                <a:latin typeface="Geist"/>
+                <a:ea typeface="Geist"/>
+                <a:cs typeface="Geist"/>
+                <a:sym typeface="Geist"/>
+              </a:rPr>
+              <a:t>løsning</a:t>
+            </a:r>
+            <a:r>
+              <a:rPr lang="en-US" sz="1800" b="0" i="0" u="none" strike="noStrike" dirty="0">
+                <a:solidFill>
+                  <a:srgbClr val="000000"/>
+                </a:solidFill>
+                <a:latin typeface="Geist"/>
+                <a:ea typeface="Geist"/>
+                <a:cs typeface="Geist"/>
+                <a:sym typeface="Geist"/>
+              </a:rPr>
+              <a:t> </a:t>
+            </a:r>
+            <a:r>
+              <a:rPr lang="en-US" sz="1800" b="0" i="0" u="none" strike="noStrike" dirty="0" err="1">
+                <a:solidFill>
+                  <a:srgbClr val="000000"/>
+                </a:solidFill>
+                <a:latin typeface="Geist"/>
+                <a:ea typeface="Geist"/>
+                <a:cs typeface="Geist"/>
+                <a:sym typeface="Geist"/>
+              </a:rPr>
+              <a:t>til</a:t>
+            </a:r>
+            <a:r>
+              <a:rPr lang="en-US" sz="1800" b="0" i="0" u="none" strike="noStrike" dirty="0">
+                <a:solidFill>
+                  <a:srgbClr val="000000"/>
+                </a:solidFill>
+                <a:latin typeface="Geist"/>
+                <a:ea typeface="Geist"/>
+                <a:cs typeface="Geist"/>
+                <a:sym typeface="Geist"/>
+              </a:rPr>
+              <a:t> </a:t>
+            </a:r>
+            <a:r>
+              <a:rPr lang="en-US" sz="1800" b="0" i="0" u="none" strike="noStrike" dirty="0" err="1">
+                <a:solidFill>
+                  <a:srgbClr val="000000"/>
+                </a:solidFill>
+                <a:latin typeface="Geist"/>
+                <a:ea typeface="Geist"/>
+                <a:cs typeface="Geist"/>
+                <a:sym typeface="Geist"/>
+              </a:rPr>
+              <a:t>en</a:t>
+            </a:r>
+            <a:r>
+              <a:rPr lang="en-US" sz="1800" b="0" i="0" u="none" strike="noStrike" dirty="0">
+                <a:solidFill>
+                  <a:srgbClr val="000000"/>
+                </a:solidFill>
+                <a:latin typeface="Geist"/>
+                <a:ea typeface="Geist"/>
+                <a:cs typeface="Geist"/>
+                <a:sym typeface="Geist"/>
+              </a:rPr>
+              <a:t> given </a:t>
+            </a:r>
+            <a:r>
+              <a:rPr lang="en-US" sz="1800" b="0" i="0" u="none" strike="noStrike" dirty="0" err="1">
+                <a:solidFill>
+                  <a:srgbClr val="000000"/>
+                </a:solidFill>
+                <a:latin typeface="Geist"/>
+                <a:ea typeface="Geist"/>
+                <a:cs typeface="Geist"/>
+                <a:sym typeface="Geist"/>
+              </a:rPr>
+              <a:t>opgave</a:t>
+            </a:r>
+            <a:r>
+              <a:rPr lang="en-US" sz="1800" b="0" i="0" u="none" strike="noStrike" dirty="0">
+                <a:solidFill>
+                  <a:srgbClr val="000000"/>
+                </a:solidFill>
+                <a:latin typeface="Geist"/>
+                <a:ea typeface="Geist"/>
+                <a:cs typeface="Geist"/>
+                <a:sym typeface="Geist"/>
+              </a:rPr>
+              <a:t>.</a:t>
+            </a:r>
+            <a:endParaRPr lang="en-US" sz="1100" dirty="0"/>
           </a:p>
           <a:p>
             <a:pPr marL="457200" indent="-406400" algn="l">
@@ -21567,18 +21868,78 @@
               <a:buChar char="●"/>
             </a:pPr>
             <a:r>
-              <a:rPr lang="en-US" sz="2000" b="1" i="0" u="none" strike="noStrike">
-                <a:solidFill>
-                  <a:srgbClr val="000000"/>
-                </a:solidFill>
-                <a:latin typeface="Geist"/>
-                <a:ea typeface="Geist"/>
-                <a:cs typeface="Geist"/>
-                <a:sym typeface="Geist"/>
-              </a:rPr>
-              <a:t>Læringsmål efter sessionen:</a:t>
-            </a:r>
-            <a:endParaRPr/>
+              <a:rPr lang="en-US" sz="2000" b="1" i="0" u="none" strike="noStrike" dirty="0" err="1">
+                <a:solidFill>
+                  <a:srgbClr val="000000"/>
+                </a:solidFill>
+                <a:latin typeface="Geist"/>
+                <a:ea typeface="Geist"/>
+                <a:cs typeface="Geist"/>
+                <a:sym typeface="Geist"/>
+              </a:rPr>
+              <a:t>Læringsmål</a:t>
+            </a:r>
+            <a:r>
+              <a:rPr lang="en-US" sz="2000" b="1" i="0" u="none" strike="noStrike" dirty="0">
+                <a:solidFill>
+                  <a:srgbClr val="000000"/>
+                </a:solidFill>
+                <a:latin typeface="Geist"/>
+                <a:ea typeface="Geist"/>
+                <a:cs typeface="Geist"/>
+                <a:sym typeface="Geist"/>
+              </a:rPr>
+              <a:t> </a:t>
+            </a:r>
+            <a:r>
+              <a:rPr lang="en-US" sz="2000" b="1" i="0" u="none" strike="noStrike" dirty="0" err="1">
+                <a:solidFill>
+                  <a:srgbClr val="000000"/>
+                </a:solidFill>
+                <a:latin typeface="Geist"/>
+                <a:ea typeface="Geist"/>
+                <a:cs typeface="Geist"/>
+                <a:sym typeface="Geist"/>
+              </a:rPr>
+              <a:t>efter</a:t>
+            </a:r>
+            <a:r>
+              <a:rPr lang="en-US" sz="2000" b="1" i="0" u="none" strike="noStrike" dirty="0">
+                <a:solidFill>
+                  <a:srgbClr val="000000"/>
+                </a:solidFill>
+                <a:latin typeface="Geist"/>
+                <a:ea typeface="Geist"/>
+                <a:cs typeface="Geist"/>
+                <a:sym typeface="Geist"/>
+              </a:rPr>
+              <a:t> </a:t>
+            </a:r>
+            <a:r>
+              <a:rPr lang="en-US" sz="2000" b="1" i="0" u="none" strike="noStrike" dirty="0" err="1">
+                <a:solidFill>
+                  <a:srgbClr val="000000"/>
+                </a:solidFill>
+                <a:latin typeface="Geist"/>
+                <a:ea typeface="Geist"/>
+                <a:cs typeface="Geist"/>
+                <a:sym typeface="Geist"/>
+              </a:rPr>
+              <a:t>sessionen</a:t>
+            </a:r>
+            <a:r>
+              <a:rPr lang="en-US" sz="2000" b="1" i="0" u="none" strike="noStrike" dirty="0">
+                <a:solidFill>
+                  <a:srgbClr val="000000"/>
+                </a:solidFill>
+                <a:latin typeface="Geist"/>
+                <a:ea typeface="Geist"/>
+                <a:cs typeface="Geist"/>
+                <a:sym typeface="Geist"/>
+              </a:rPr>
+              <a:t>:</a:t>
+            </a:r>
+            <a:endParaRPr dirty="0"/>
           </a:p>
           <a:p>
             <a:pPr marL="304800" indent="0" algn="l">
@@ -21587,6 +21948,269 @@
               </a:lnSpc>
             </a:pPr>
             <a:r>
+              <a:rPr lang="en-US" sz="1700" b="0" i="0" u="none" strike="noStrike" dirty="0">
+                <a:solidFill>
+                  <a:srgbClr val="000000"/>
+                </a:solidFill>
+                <a:latin typeface="Geist"/>
+                <a:ea typeface="Geist"/>
+                <a:cs typeface="Geist"/>
+                <a:sym typeface="Geist"/>
+              </a:rPr>
+              <a:t>1. </a:t>
+            </a:r>
+            <a:r>
+              <a:rPr lang="en-US" sz="1700" b="0" i="0" u="none" strike="noStrike" dirty="0" err="1">
+                <a:solidFill>
+                  <a:srgbClr val="000000"/>
+                </a:solidFill>
+                <a:latin typeface="Geist"/>
+                <a:ea typeface="Geist"/>
+                <a:cs typeface="Geist"/>
+                <a:sym typeface="Geist"/>
+              </a:rPr>
+              <a:t>Definere</a:t>
+            </a:r>
+            <a:r>
+              <a:rPr lang="en-US" sz="1700" b="0" i="0" u="none" strike="noStrike" dirty="0">
+                <a:solidFill>
+                  <a:srgbClr val="000000"/>
+                </a:solidFill>
+                <a:latin typeface="Geist"/>
+                <a:ea typeface="Geist"/>
+                <a:cs typeface="Geist"/>
+                <a:sym typeface="Geist"/>
+              </a:rPr>
+              <a:t> </a:t>
+            </a:r>
+            <a:r>
+              <a:rPr lang="en-US" sz="1700" b="0" i="0" u="none" strike="noStrike" dirty="0" err="1">
+                <a:solidFill>
+                  <a:srgbClr val="000000"/>
+                </a:solidFill>
+                <a:latin typeface="Geist"/>
+                <a:ea typeface="Geist"/>
+                <a:cs typeface="Geist"/>
+                <a:sym typeface="Geist"/>
+              </a:rPr>
+              <a:t>hvad</a:t>
+            </a:r>
+            <a:r>
+              <a:rPr lang="en-US" sz="1700" b="0" i="0" u="none" strike="noStrike" dirty="0">
+                <a:solidFill>
+                  <a:srgbClr val="000000"/>
+                </a:solidFill>
+                <a:latin typeface="Geist"/>
+                <a:ea typeface="Geist"/>
+                <a:cs typeface="Geist"/>
+                <a:sym typeface="Geist"/>
+              </a:rPr>
+              <a:t> </a:t>
+            </a:r>
+            <a:r>
+              <a:rPr lang="en-US" sz="1700" b="0" i="0" u="none" strike="noStrike" dirty="0" err="1">
+                <a:solidFill>
+                  <a:srgbClr val="000000"/>
+                </a:solidFill>
+                <a:latin typeface="Geist"/>
+                <a:ea typeface="Geist"/>
+                <a:cs typeface="Geist"/>
+                <a:sym typeface="Geist"/>
+              </a:rPr>
+              <a:t>en</a:t>
+            </a:r>
+            <a:r>
+              <a:rPr lang="en-US" sz="1700" b="0" i="0" u="none" strike="noStrike" dirty="0">
+                <a:solidFill>
+                  <a:srgbClr val="000000"/>
+                </a:solidFill>
+                <a:latin typeface="Geist"/>
+                <a:ea typeface="Geist"/>
+                <a:cs typeface="Geist"/>
+                <a:sym typeface="Geist"/>
+              </a:rPr>
+              <a:t> </a:t>
+            </a:r>
+            <a:r>
+              <a:rPr lang="en-US" sz="1700" b="0" i="0" u="none" strike="noStrike" dirty="0" err="1">
+                <a:solidFill>
+                  <a:srgbClr val="000000"/>
+                </a:solidFill>
+                <a:latin typeface="Geist"/>
+                <a:ea typeface="Geist"/>
+                <a:cs typeface="Geist"/>
+                <a:sym typeface="Geist"/>
+              </a:rPr>
+              <a:t>algoritme</a:t>
+            </a:r>
+            <a:r>
+              <a:rPr lang="en-US" sz="1700" b="0" i="0" u="none" strike="noStrike" dirty="0">
+                <a:solidFill>
+                  <a:srgbClr val="000000"/>
+                </a:solidFill>
+                <a:latin typeface="Geist"/>
+                <a:ea typeface="Geist"/>
+                <a:cs typeface="Geist"/>
+                <a:sym typeface="Geist"/>
+              </a:rPr>
+              <a:t> er </a:t>
+            </a:r>
+            <a:r>
+              <a:rPr lang="en-US" sz="1700" b="0" i="0" u="none" strike="noStrike" dirty="0" err="1">
+                <a:solidFill>
+                  <a:srgbClr val="000000"/>
+                </a:solidFill>
+                <a:latin typeface="Geist"/>
+                <a:ea typeface="Geist"/>
+                <a:cs typeface="Geist"/>
+                <a:sym typeface="Geist"/>
+              </a:rPr>
+              <a:t>og</a:t>
+            </a:r>
+            <a:r>
+              <a:rPr lang="en-US" sz="1700" b="0" i="0" u="none" strike="noStrike" dirty="0">
+                <a:solidFill>
+                  <a:srgbClr val="000000"/>
+                </a:solidFill>
+                <a:latin typeface="Geist"/>
+                <a:ea typeface="Geist"/>
+                <a:cs typeface="Geist"/>
+                <a:sym typeface="Geist"/>
+              </a:rPr>
+              <a:t> give </a:t>
+            </a:r>
+            <a:r>
+              <a:rPr lang="en-US" sz="1700" b="0" i="0" u="none" strike="noStrike" dirty="0" err="1">
+                <a:solidFill>
+                  <a:srgbClr val="000000"/>
+                </a:solidFill>
+                <a:latin typeface="Geist"/>
+                <a:ea typeface="Geist"/>
+                <a:cs typeface="Geist"/>
+                <a:sym typeface="Geist"/>
+              </a:rPr>
+              <a:t>eksempler</a:t>
+            </a:r>
+            <a:r>
+              <a:rPr lang="en-US" sz="1700" b="0" i="0" u="none" strike="noStrike" dirty="0">
+                <a:solidFill>
+                  <a:srgbClr val="000000"/>
+                </a:solidFill>
+                <a:latin typeface="Geist"/>
+                <a:ea typeface="Geist"/>
+                <a:cs typeface="Geist"/>
+                <a:sym typeface="Geist"/>
+              </a:rPr>
+              <a:t> </a:t>
+            </a:r>
+            <a:r>
+              <a:rPr lang="en-US" sz="1700" b="0" i="0" u="none" strike="noStrike" dirty="0" err="1">
+                <a:solidFill>
+                  <a:srgbClr val="000000"/>
+                </a:solidFill>
+                <a:latin typeface="Geist"/>
+                <a:ea typeface="Geist"/>
+                <a:cs typeface="Geist"/>
+                <a:sym typeface="Geist"/>
+              </a:rPr>
+              <a:t>fra</a:t>
+            </a:r>
+            <a:r>
+              <a:rPr lang="en-US" sz="1700" b="0" i="0" u="none" strike="noStrike" dirty="0">
+                <a:solidFill>
+                  <a:srgbClr val="000000"/>
+                </a:solidFill>
+                <a:latin typeface="Geist"/>
+                <a:ea typeface="Geist"/>
+                <a:cs typeface="Geist"/>
+                <a:sym typeface="Geist"/>
+              </a:rPr>
+              <a:t> </a:t>
+            </a:r>
+            <a:r>
+              <a:rPr lang="en-US" sz="1700" b="0" i="0" u="none" strike="noStrike" dirty="0" err="1">
+                <a:solidFill>
+                  <a:srgbClr val="000000"/>
+                </a:solidFill>
+                <a:latin typeface="Geist"/>
+                <a:ea typeface="Geist"/>
+                <a:cs typeface="Geist"/>
+                <a:sym typeface="Geist"/>
+              </a:rPr>
+              <a:t>hverdagen</a:t>
+            </a:r>
+            <a:r>
+              <a:rPr lang="en-US" sz="1700" b="0" i="0" u="none" strike="noStrike" dirty="0">
+                <a:solidFill>
+                  <a:srgbClr val="000000"/>
+                </a:solidFill>
+                <a:latin typeface="Geist"/>
+                <a:ea typeface="Geist"/>
+                <a:cs typeface="Geist"/>
+                <a:sym typeface="Geist"/>
+              </a:rPr>
+              <a:t>.</a:t>
+            </a:r>
+            <a:br>
+              <a:rPr lang="en-US" sz="1800" b="0" i="0" u="none" strike="noStrike" dirty="0">
+                <a:solidFill>
+                  <a:srgbClr val="000000"/>
+                </a:solidFill>
+                <a:latin typeface="Geist"/>
+                <a:ea typeface="Geist"/>
+                <a:cs typeface="Geist"/>
+                <a:sym typeface="Geist"/>
+              </a:rPr>
+            </a:br>
+            <a:r>
+              <a:rPr lang="en-US" sz="1700" b="0" i="0" u="none" strike="noStrike" dirty="0">
+                <a:solidFill>
+                  <a:srgbClr val="000000"/>
+                </a:solidFill>
+                <a:latin typeface="Geist"/>
+                <a:ea typeface="Geist"/>
+                <a:cs typeface="Geist"/>
+                <a:sym typeface="Geist"/>
+              </a:rPr>
+              <a:t>2. </a:t>
+            </a:r>
+            <a:r>
+              <a:rPr lang="en-US" sz="1700" b="0" i="0" u="none" strike="noStrike" dirty="0" err="1">
+                <a:solidFill>
+                  <a:srgbClr val="000000"/>
+                </a:solidFill>
+                <a:latin typeface="Geist"/>
+                <a:ea typeface="Geist"/>
+                <a:cs typeface="Geist"/>
+                <a:sym typeface="Geist"/>
+              </a:rPr>
+              <a:t>Forklare</a:t>
+            </a:r>
+            <a:r>
+              <a:rPr lang="en-US" sz="1700" b="0" i="0" u="none" strike="noStrike" dirty="0">
+                <a:solidFill>
+                  <a:srgbClr val="000000"/>
+                </a:solidFill>
+                <a:latin typeface="Geist"/>
+                <a:ea typeface="Geist"/>
+                <a:cs typeface="Geist"/>
+                <a:sym typeface="Geist"/>
+              </a:rPr>
+              <a:t> </a:t>
+            </a:r>
+            <a:r>
+              <a:rPr lang="en-US" sz="1700" b="0" i="0" u="none" strike="noStrike" dirty="0" err="1">
+                <a:solidFill>
+                  <a:srgbClr val="000000"/>
+                </a:solidFill>
+                <a:latin typeface="Geist"/>
+                <a:ea typeface="Geist"/>
+                <a:cs typeface="Geist"/>
+                <a:sym typeface="Geist"/>
+              </a:rPr>
+              <a:t>princippet</a:t>
+            </a:r>
+            <a:r>
               <a:rPr lang="en-US" sz="1700" b="0" i="0" u="none" strike="noStrike">
                 <a:solidFill>
                   <a:srgbClr val="000000"/>
@@ -21596,10 +22220,178 @@
                 <a:cs typeface="Geist"/>
                 <a:sym typeface="Geist"/>
               </a:rPr>
-              <a:t>1. Definere hvad en algoritme er og give eksempler fra hverdagen.</a:t>
+              <a:t> om </a:t>
+            </a:r>
+            <a:r>
+              <a:rPr lang="en-US" sz="1700" b="1" i="0" u="none" strike="noStrike">
+                <a:solidFill>
+                  <a:srgbClr val="000000"/>
+                </a:solidFill>
+                <a:latin typeface="Geist"/>
+                <a:ea typeface="Geist"/>
+                <a:cs typeface="Geist"/>
+                <a:sym typeface="Geist"/>
+              </a:rPr>
+              <a:t>nedbrydning</a:t>
+            </a:r>
+            <a:r>
+              <a:rPr lang="en-US" sz="1700" b="0" i="0" u="none" strike="noStrike" dirty="0">
+                <a:solidFill>
+                  <a:srgbClr val="000000"/>
+                </a:solidFill>
+                <a:latin typeface="Geist"/>
+                <a:ea typeface="Geist"/>
+                <a:cs typeface="Geist"/>
+                <a:sym typeface="Geist"/>
+              </a:rPr>
+              <a:t>(at </a:t>
+            </a:r>
+            <a:r>
+              <a:rPr lang="en-US" sz="1700" b="0" i="0" u="none" strike="noStrike" dirty="0" err="1">
+                <a:solidFill>
+                  <a:srgbClr val="000000"/>
+                </a:solidFill>
+                <a:latin typeface="Geist"/>
+                <a:ea typeface="Geist"/>
+                <a:cs typeface="Geist"/>
+                <a:sym typeface="Geist"/>
+              </a:rPr>
+              <a:t>bryde</a:t>
+            </a:r>
+            <a:r>
+              <a:rPr lang="en-US" sz="1700" b="0" i="0" u="none" strike="noStrike" dirty="0">
+                <a:solidFill>
+                  <a:srgbClr val="000000"/>
+                </a:solidFill>
+                <a:latin typeface="Geist"/>
+                <a:ea typeface="Geist"/>
+                <a:cs typeface="Geist"/>
+                <a:sym typeface="Geist"/>
+              </a:rPr>
+              <a:t> store </a:t>
+            </a:r>
+            <a:r>
+              <a:rPr lang="en-US" sz="1700" b="0" i="0" u="none" strike="noStrike" dirty="0" err="1">
+                <a:solidFill>
+                  <a:srgbClr val="000000"/>
+                </a:solidFill>
+                <a:latin typeface="Geist"/>
+                <a:ea typeface="Geist"/>
+                <a:cs typeface="Geist"/>
+                <a:sym typeface="Geist"/>
+              </a:rPr>
+              <a:t>problemer</a:t>
+            </a:r>
+            <a:r>
+              <a:rPr lang="en-US" sz="1700" b="0" i="0" u="none" strike="noStrike" dirty="0">
+                <a:solidFill>
+                  <a:srgbClr val="000000"/>
+                </a:solidFill>
+                <a:latin typeface="Geist"/>
+                <a:ea typeface="Geist"/>
+                <a:cs typeface="Geist"/>
+                <a:sym typeface="Geist"/>
+              </a:rPr>
+              <a:t> </a:t>
+            </a:r>
+            <a:r>
+              <a:rPr lang="en-US" sz="1700" b="0" i="0" u="none" strike="noStrike" dirty="0" err="1">
+                <a:solidFill>
+                  <a:srgbClr val="000000"/>
+                </a:solidFill>
+                <a:latin typeface="Geist"/>
+                <a:ea typeface="Geist"/>
+                <a:cs typeface="Geist"/>
+                <a:sym typeface="Geist"/>
+              </a:rPr>
+              <a:t>ned</a:t>
+            </a:r>
+            <a:r>
+              <a:rPr lang="en-US" sz="1700" b="0" i="0" u="none" strike="noStrike" dirty="0">
+                <a:solidFill>
+                  <a:srgbClr val="000000"/>
+                </a:solidFill>
+                <a:latin typeface="Geist"/>
+                <a:ea typeface="Geist"/>
+                <a:cs typeface="Geist"/>
+                <a:sym typeface="Geist"/>
+              </a:rPr>
+              <a:t> </a:t>
+            </a:r>
+            <a:r>
+              <a:rPr lang="en-US" sz="1700" b="0" i="0" u="none" strike="noStrike" dirty="0" err="1">
+                <a:solidFill>
+                  <a:srgbClr val="000000"/>
+                </a:solidFill>
+                <a:latin typeface="Geist"/>
+                <a:ea typeface="Geist"/>
+                <a:cs typeface="Geist"/>
+                <a:sym typeface="Geist"/>
+              </a:rPr>
+              <a:t>i</a:t>
+            </a:r>
+            <a:r>
+              <a:rPr lang="en-US" sz="1700" b="0" i="0" u="none" strike="noStrike" dirty="0">
+                <a:solidFill>
+                  <a:srgbClr val="000000"/>
+                </a:solidFill>
+                <a:latin typeface="Geist"/>
+                <a:ea typeface="Geist"/>
+                <a:cs typeface="Geist"/>
+                <a:sym typeface="Geist"/>
+              </a:rPr>
+              <a:t> </a:t>
+            </a:r>
+            <a:r>
+              <a:rPr lang="en-US" sz="1700" b="0" i="0" u="none" strike="noStrike" dirty="0" err="1">
+                <a:solidFill>
+                  <a:srgbClr val="000000"/>
+                </a:solidFill>
+                <a:latin typeface="Geist"/>
+                <a:ea typeface="Geist"/>
+                <a:cs typeface="Geist"/>
+                <a:sym typeface="Geist"/>
+              </a:rPr>
+              <a:t>mindre</a:t>
+            </a:r>
+            <a:r>
+              <a:rPr lang="en-US" sz="1700" b="0" i="0" u="none" strike="noStrike" dirty="0">
+                <a:solidFill>
+                  <a:srgbClr val="000000"/>
+                </a:solidFill>
+                <a:latin typeface="Geist"/>
+                <a:ea typeface="Geist"/>
+                <a:cs typeface="Geist"/>
+                <a:sym typeface="Geist"/>
+              </a:rPr>
+              <a:t> </a:t>
+            </a:r>
+            <a:r>
+              <a:rPr lang="en-US" sz="1700" b="0" i="0" u="none" strike="noStrike" dirty="0" err="1">
+                <a:solidFill>
+                  <a:srgbClr val="000000"/>
+                </a:solidFill>
+                <a:latin typeface="Geist"/>
+                <a:ea typeface="Geist"/>
+                <a:cs typeface="Geist"/>
+                <a:sym typeface="Geist"/>
+              </a:rPr>
+              <a:t>delopgaver</a:t>
+            </a:r>
+            <a:r>
+              <a:rPr lang="en-US" sz="1700" b="0" i="0" u="none" strike="noStrike" dirty="0">
+                <a:solidFill>
+                  <a:srgbClr val="000000"/>
+                </a:solidFill>
+                <a:latin typeface="Geist"/>
+                <a:ea typeface="Geist"/>
+                <a:cs typeface="Geist"/>
+                <a:sym typeface="Geist"/>
+              </a:rPr>
+              <a:t>).</a:t>
             </a:r>
             <a:br>
-              <a:rPr lang="en-US" sz="1800" b="0" i="0" u="none" strike="noStrike">
+              <a:rPr lang="en-US" sz="1800" b="0" i="0" u="none" strike="noStrike" dirty="0">
                 <a:solidFill>
                   <a:srgbClr val="000000"/>
                 </a:solidFill>
@@ -21610,43 +22402,211 @@
               </a:rPr>
             </a:br>
             <a:r>
-              <a:rPr lang="en-US" sz="1700" b="0" i="0" u="none" strike="noStrike">
-                <a:solidFill>
-                  <a:srgbClr val="000000"/>
-                </a:solidFill>
-                <a:latin typeface="Geist"/>
-                <a:ea typeface="Geist"/>
-                <a:cs typeface="Geist"/>
-                <a:sym typeface="Geist"/>
-              </a:rPr>
-              <a:t>2. Forklare princippet om</a:t>
-            </a:r>
-            <a:r>
-              <a:rPr lang="en-US" sz="1700" b="1" i="0" u="none" strike="noStrike">
-                <a:solidFill>
-                  <a:srgbClr val="000000"/>
-                </a:solidFill>
-                <a:latin typeface="Geist"/>
-                <a:ea typeface="Geist"/>
-                <a:cs typeface="Geist"/>
-                <a:sym typeface="Geist"/>
-              </a:rPr>
-              <a:t>nedbrydning</a:t>
-            </a:r>
-            <a:r>
-              <a:rPr lang="en-US" sz="1700" b="0" i="0" u="none" strike="noStrike">
-                <a:solidFill>
-                  <a:srgbClr val="000000"/>
-                </a:solidFill>
-                <a:latin typeface="Geist"/>
-                <a:ea typeface="Geist"/>
-                <a:cs typeface="Geist"/>
-                <a:sym typeface="Geist"/>
-              </a:rPr>
-              <a:t>(at bryde store problemer ned i mindre delopgaver).</a:t>
+              <a:rPr lang="en-US" sz="1700" b="0" i="0" u="none" strike="noStrike" dirty="0">
+                <a:solidFill>
+                  <a:srgbClr val="000000"/>
+                </a:solidFill>
+                <a:latin typeface="Geist"/>
+                <a:ea typeface="Geist"/>
+                <a:cs typeface="Geist"/>
+                <a:sym typeface="Geist"/>
+              </a:rPr>
+              <a:t>3. </a:t>
+            </a:r>
+            <a:r>
+              <a:rPr lang="en-US" sz="1700" b="0" i="0" u="none" strike="noStrike" dirty="0" err="1">
+                <a:solidFill>
+                  <a:srgbClr val="000000"/>
+                </a:solidFill>
+                <a:latin typeface="Geist"/>
+                <a:ea typeface="Geist"/>
+                <a:cs typeface="Geist"/>
+                <a:sym typeface="Geist"/>
+              </a:rPr>
+              <a:t>Genkende</a:t>
+            </a:r>
+            <a:r>
+              <a:rPr lang="en-US" sz="1700" b="0" i="0" u="none" strike="noStrike" dirty="0">
+                <a:solidFill>
+                  <a:srgbClr val="000000"/>
+                </a:solidFill>
+                <a:latin typeface="Geist"/>
+                <a:ea typeface="Geist"/>
+                <a:cs typeface="Geist"/>
+                <a:sym typeface="Geist"/>
+              </a:rPr>
+              <a:t> de </a:t>
+            </a:r>
+            <a:r>
+              <a:rPr lang="en-US" sz="1700" b="0" i="0" u="none" strike="noStrike" dirty="0" err="1">
+                <a:solidFill>
+                  <a:srgbClr val="000000"/>
+                </a:solidFill>
+                <a:latin typeface="Geist"/>
+                <a:ea typeface="Geist"/>
+                <a:cs typeface="Geist"/>
+                <a:sym typeface="Geist"/>
+              </a:rPr>
+              <a:t>tre</a:t>
+            </a:r>
+            <a:r>
+              <a:rPr lang="en-US" sz="1700" b="0" i="0" u="none" strike="noStrike" dirty="0">
+                <a:solidFill>
+                  <a:srgbClr val="000000"/>
+                </a:solidFill>
+                <a:latin typeface="Geist"/>
+                <a:ea typeface="Geist"/>
+                <a:cs typeface="Geist"/>
+                <a:sym typeface="Geist"/>
+              </a:rPr>
+              <a:t> </a:t>
+            </a:r>
+            <a:r>
+              <a:rPr lang="en-US" sz="1700" b="0" i="0" u="none" strike="noStrike" dirty="0" err="1">
+                <a:solidFill>
+                  <a:srgbClr val="000000"/>
+                </a:solidFill>
+                <a:latin typeface="Geist"/>
+                <a:ea typeface="Geist"/>
+                <a:cs typeface="Geist"/>
+                <a:sym typeface="Geist"/>
+              </a:rPr>
+              <a:t>grundlæggende</a:t>
+            </a:r>
+            <a:r>
+              <a:rPr lang="en-US" sz="1700" b="0" i="0" u="none" strike="noStrike" dirty="0">
+                <a:solidFill>
+                  <a:srgbClr val="000000"/>
+                </a:solidFill>
+                <a:latin typeface="Geist"/>
+                <a:ea typeface="Geist"/>
+                <a:cs typeface="Geist"/>
+                <a:sym typeface="Geist"/>
+              </a:rPr>
+              <a:t> </a:t>
+            </a:r>
+            <a:r>
+              <a:rPr lang="en-US" sz="1700" b="0" i="0" u="none" strike="noStrike" dirty="0" err="1">
+                <a:solidFill>
+                  <a:srgbClr val="000000"/>
+                </a:solidFill>
+                <a:latin typeface="Geist"/>
+                <a:ea typeface="Geist"/>
+                <a:cs typeface="Geist"/>
+                <a:sym typeface="Geist"/>
+              </a:rPr>
+              <a:t>kontrolstrukturer</a:t>
+            </a:r>
+            <a:r>
+              <a:rPr lang="en-US" sz="1700" b="0" i="0" u="none" strike="noStrike" dirty="0">
+                <a:solidFill>
+                  <a:srgbClr val="000000"/>
+                </a:solidFill>
+                <a:latin typeface="Geist"/>
+                <a:ea typeface="Geist"/>
+                <a:cs typeface="Geist"/>
+                <a:sym typeface="Geist"/>
+              </a:rPr>
+              <a:t>: </a:t>
+            </a:r>
+            <a:r>
+              <a:rPr lang="en-US" sz="1700" b="0" i="0" u="none" strike="noStrike" dirty="0" err="1">
+                <a:solidFill>
+                  <a:srgbClr val="000000"/>
+                </a:solidFill>
+                <a:latin typeface="Geist"/>
+                <a:ea typeface="Geist"/>
+                <a:cs typeface="Geist"/>
+                <a:sym typeface="Geist"/>
+              </a:rPr>
+              <a:t>sekvens</a:t>
+            </a:r>
+            <a:r>
+              <a:rPr lang="en-US" sz="1700" b="0" i="0" u="none" strike="noStrike" dirty="0">
+                <a:solidFill>
+                  <a:srgbClr val="000000"/>
+                </a:solidFill>
+                <a:latin typeface="Geist"/>
+                <a:ea typeface="Geist"/>
+                <a:cs typeface="Geist"/>
+                <a:sym typeface="Geist"/>
+              </a:rPr>
+              <a:t>, </a:t>
+            </a:r>
+            <a:r>
+              <a:rPr lang="en-US" sz="1700" b="0" i="0" u="none" strike="noStrike" dirty="0" err="1">
+                <a:solidFill>
+                  <a:srgbClr val="000000"/>
+                </a:solidFill>
+                <a:latin typeface="Geist"/>
+                <a:ea typeface="Geist"/>
+                <a:cs typeface="Geist"/>
+                <a:sym typeface="Geist"/>
+              </a:rPr>
+              <a:t>valg</a:t>
+            </a:r>
+            <a:r>
+              <a:rPr lang="en-US" sz="1700" b="0" i="0" u="none" strike="noStrike" dirty="0">
+                <a:solidFill>
+                  <a:srgbClr val="000000"/>
+                </a:solidFill>
+                <a:latin typeface="Geist"/>
+                <a:ea typeface="Geist"/>
+                <a:cs typeface="Geist"/>
+                <a:sym typeface="Geist"/>
+              </a:rPr>
+              <a:t> </a:t>
+            </a:r>
+            <a:r>
+              <a:rPr lang="en-US" sz="1700" b="0" i="0" u="none" strike="noStrike" dirty="0" err="1">
+                <a:solidFill>
+                  <a:srgbClr val="000000"/>
+                </a:solidFill>
+                <a:latin typeface="Geist"/>
+                <a:ea typeface="Geist"/>
+                <a:cs typeface="Geist"/>
+                <a:sym typeface="Geist"/>
+              </a:rPr>
+              <a:t>og</a:t>
+            </a:r>
+            <a:r>
+              <a:rPr lang="en-US" sz="1700" b="0" i="0" u="none" strike="noStrike" dirty="0">
+                <a:solidFill>
+                  <a:srgbClr val="000000"/>
+                </a:solidFill>
+                <a:latin typeface="Geist"/>
+                <a:ea typeface="Geist"/>
+                <a:cs typeface="Geist"/>
+                <a:sym typeface="Geist"/>
+              </a:rPr>
+              <a:t> </a:t>
+            </a:r>
+            <a:r>
+              <a:rPr lang="en-US" sz="1700" b="0" i="0" u="none" strike="noStrike" dirty="0" err="1">
+                <a:solidFill>
+                  <a:srgbClr val="000000"/>
+                </a:solidFill>
+                <a:latin typeface="Geist"/>
+                <a:ea typeface="Geist"/>
+                <a:cs typeface="Geist"/>
+                <a:sym typeface="Geist"/>
+              </a:rPr>
+              <a:t>gentagelse</a:t>
+            </a:r>
+            <a:r>
+              <a:rPr lang="en-US" sz="1700" b="0" i="0" u="none" strike="noStrike" dirty="0">
+                <a:solidFill>
+                  <a:srgbClr val="000000"/>
+                </a:solidFill>
+                <a:latin typeface="Geist"/>
+                <a:ea typeface="Geist"/>
+                <a:cs typeface="Geist"/>
+                <a:sym typeface="Geist"/>
+              </a:rPr>
+              <a:t>.</a:t>
             </a:r>
             <a:br>
-              <a:rPr lang="en-US" sz="1800" b="0" i="0" u="none" strike="noStrike">
+              <a:rPr lang="en-US" sz="1800" b="0" i="0" u="none" strike="noStrike" dirty="0">
                 <a:solidFill>
                   <a:srgbClr val="000000"/>
                 </a:solidFill>
@@ -21657,41 +22617,330 @@
               </a:rPr>
             </a:br>
             <a:r>
-              <a:rPr lang="en-US" sz="1700" b="0" i="0" u="none" strike="noStrike">
-                <a:solidFill>
-                  <a:srgbClr val="000000"/>
-                </a:solidFill>
-                <a:latin typeface="Geist"/>
-                <a:ea typeface="Geist"/>
-                <a:cs typeface="Geist"/>
-                <a:sym typeface="Geist"/>
-              </a:rPr>
-              <a:t>3. Genkende de tre grundlæggende kontrolstrukturer: sekvens, valg og gentagelse.</a:t>
-            </a:r>
-            <a:br>
-              <a:rPr lang="en-US" sz="1800" b="0" i="0" u="none" strike="noStrike">
-                <a:solidFill>
-                  <a:srgbClr val="000000"/>
-                </a:solidFill>
-                <a:latin typeface="Geist"/>
-                <a:ea typeface="Geist"/>
-                <a:cs typeface="Geist"/>
-                <a:sym typeface="Geist"/>
-              </a:rPr>
-            </a:br>
-            <a:r>
-              <a:rPr lang="en-US" sz="1700" b="0" i="0" u="none" strike="noStrike">
-                <a:solidFill>
-                  <a:srgbClr val="000000"/>
-                </a:solidFill>
-                <a:latin typeface="Geist"/>
-                <a:ea typeface="Geist"/>
-                <a:cs typeface="Geist"/>
-                <a:sym typeface="Geist"/>
-              </a:rPr>
-              <a:t>4. Skrive en trinvise algoritme til en simpel opgave (f.eks. at beregne gennemsnittet af tal).</a:t>
-            </a:r>
-            <a:endParaRPr/>
+              <a:rPr lang="en-US" sz="1700" b="0" i="0" u="none" strike="noStrike" dirty="0">
+                <a:solidFill>
+                  <a:srgbClr val="000000"/>
+                </a:solidFill>
+                <a:latin typeface="Geist"/>
+                <a:ea typeface="Geist"/>
+                <a:cs typeface="Geist"/>
+                <a:sym typeface="Geist"/>
+              </a:rPr>
+              <a:t>4. </a:t>
+            </a:r>
+            <a:r>
+              <a:rPr lang="en-US" sz="1700" b="0" i="0" u="none" strike="noStrike" dirty="0" err="1">
+                <a:solidFill>
+                  <a:srgbClr val="000000"/>
+                </a:solidFill>
+                <a:latin typeface="Geist"/>
+                <a:ea typeface="Geist"/>
+                <a:cs typeface="Geist"/>
+                <a:sym typeface="Geist"/>
+              </a:rPr>
+              <a:t>Skrive</a:t>
+            </a:r>
+            <a:r>
+              <a:rPr lang="en-US" sz="1700" b="0" i="0" u="none" strike="noStrike" dirty="0">
+                <a:solidFill>
+                  <a:srgbClr val="000000"/>
+                </a:solidFill>
+                <a:latin typeface="Geist"/>
+                <a:ea typeface="Geist"/>
+                <a:cs typeface="Geist"/>
+                <a:sym typeface="Geist"/>
+              </a:rPr>
+              <a:t> </a:t>
+            </a:r>
+            <a:r>
+              <a:rPr lang="en-US" sz="1700" b="0" i="0" u="none" strike="noStrike" dirty="0" err="1">
+                <a:solidFill>
+                  <a:srgbClr val="000000"/>
+                </a:solidFill>
+                <a:latin typeface="Geist"/>
+                <a:ea typeface="Geist"/>
+                <a:cs typeface="Geist"/>
+                <a:sym typeface="Geist"/>
+              </a:rPr>
+              <a:t>en</a:t>
+            </a:r>
+            <a:r>
+              <a:rPr lang="en-US" sz="1700" b="0" i="0" u="none" strike="noStrike" dirty="0">
+                <a:solidFill>
+                  <a:srgbClr val="000000"/>
+                </a:solidFill>
+                <a:latin typeface="Geist"/>
+                <a:ea typeface="Geist"/>
+                <a:cs typeface="Geist"/>
+                <a:sym typeface="Geist"/>
+              </a:rPr>
+              <a:t> </a:t>
+            </a:r>
+            <a:r>
+              <a:rPr lang="en-US" sz="1700" b="0" i="0" u="none" strike="noStrike" dirty="0" err="1">
+                <a:solidFill>
+                  <a:srgbClr val="000000"/>
+                </a:solidFill>
+                <a:latin typeface="Geist"/>
+                <a:ea typeface="Geist"/>
+                <a:cs typeface="Geist"/>
+                <a:sym typeface="Geist"/>
+              </a:rPr>
+              <a:t>trinvise</a:t>
+            </a:r>
+            <a:r>
+              <a:rPr lang="en-US" sz="1700" b="0" i="0" u="none" strike="noStrike" dirty="0">
+                <a:solidFill>
+                  <a:srgbClr val="000000"/>
+                </a:solidFill>
+                <a:latin typeface="Geist"/>
+                <a:ea typeface="Geist"/>
+                <a:cs typeface="Geist"/>
+                <a:sym typeface="Geist"/>
+              </a:rPr>
+              <a:t> </a:t>
+            </a:r>
+            <a:r>
+              <a:rPr lang="en-US" sz="1700" b="0" i="0" u="none" strike="noStrike" dirty="0" err="1">
+                <a:solidFill>
+                  <a:srgbClr val="000000"/>
+                </a:solidFill>
+                <a:latin typeface="Geist"/>
+                <a:ea typeface="Geist"/>
+                <a:cs typeface="Geist"/>
+                <a:sym typeface="Geist"/>
+              </a:rPr>
+              <a:t>algoritme</a:t>
+            </a:r>
+            <a:r>
+              <a:rPr lang="en-US" sz="1700" b="0" i="0" u="none" strike="noStrike" dirty="0">
+                <a:solidFill>
+                  <a:srgbClr val="000000"/>
+                </a:solidFill>
+                <a:latin typeface="Geist"/>
+                <a:ea typeface="Geist"/>
+                <a:cs typeface="Geist"/>
+                <a:sym typeface="Geist"/>
+              </a:rPr>
+              <a:t> </a:t>
+            </a:r>
+            <a:r>
+              <a:rPr lang="en-US" sz="1700" b="0" i="0" u="none" strike="noStrike" dirty="0" err="1">
+                <a:solidFill>
+                  <a:srgbClr val="000000"/>
+                </a:solidFill>
+                <a:latin typeface="Geist"/>
+                <a:ea typeface="Geist"/>
+                <a:cs typeface="Geist"/>
+                <a:sym typeface="Geist"/>
+              </a:rPr>
+              <a:t>til</a:t>
+            </a:r>
+            <a:r>
+              <a:rPr lang="en-US" sz="1700" b="0" i="0" u="none" strike="noStrike" dirty="0">
+                <a:solidFill>
+                  <a:srgbClr val="000000"/>
+                </a:solidFill>
+                <a:latin typeface="Geist"/>
+                <a:ea typeface="Geist"/>
+                <a:cs typeface="Geist"/>
+                <a:sym typeface="Geist"/>
+              </a:rPr>
+              <a:t> </a:t>
+            </a:r>
+            <a:r>
+              <a:rPr lang="en-US" sz="1700" b="0" i="0" u="none" strike="noStrike" dirty="0" err="1">
+                <a:solidFill>
+                  <a:srgbClr val="000000"/>
+                </a:solidFill>
+                <a:latin typeface="Geist"/>
+                <a:ea typeface="Geist"/>
+                <a:cs typeface="Geist"/>
+                <a:sym typeface="Geist"/>
+              </a:rPr>
+              <a:t>en</a:t>
+            </a:r>
+            <a:r>
+              <a:rPr lang="en-US" sz="1700" b="0" i="0" u="none" strike="noStrike" dirty="0">
+                <a:solidFill>
+                  <a:srgbClr val="000000"/>
+                </a:solidFill>
+                <a:latin typeface="Geist"/>
+                <a:ea typeface="Geist"/>
+                <a:cs typeface="Geist"/>
+                <a:sym typeface="Geist"/>
+              </a:rPr>
+              <a:t> </a:t>
+            </a:r>
+            <a:r>
+              <a:rPr lang="en-US" sz="1700" b="0" i="0" u="none" strike="noStrike" dirty="0" err="1">
+                <a:solidFill>
+                  <a:srgbClr val="000000"/>
+                </a:solidFill>
+                <a:latin typeface="Geist"/>
+                <a:ea typeface="Geist"/>
+                <a:cs typeface="Geist"/>
+                <a:sym typeface="Geist"/>
+              </a:rPr>
+              <a:t>simpel</a:t>
+            </a:r>
+            <a:r>
+              <a:rPr lang="en-US" sz="1700" b="0" i="0" u="none" strike="noStrike" dirty="0">
+                <a:solidFill>
+                  <a:srgbClr val="000000"/>
+                </a:solidFill>
+                <a:latin typeface="Geist"/>
+                <a:ea typeface="Geist"/>
+                <a:cs typeface="Geist"/>
+                <a:sym typeface="Geist"/>
+              </a:rPr>
+              <a:t> </a:t>
+            </a:r>
+            <a:r>
+              <a:rPr lang="en-US" sz="1700" b="0" i="0" u="none" strike="noStrike" dirty="0" err="1">
+                <a:solidFill>
+                  <a:srgbClr val="000000"/>
+                </a:solidFill>
+                <a:latin typeface="Geist"/>
+                <a:ea typeface="Geist"/>
+                <a:cs typeface="Geist"/>
+                <a:sym typeface="Geist"/>
+              </a:rPr>
+              <a:t>opgave</a:t>
+            </a:r>
+            <a:r>
+              <a:rPr lang="en-US" sz="1700" b="0" i="0" u="none" strike="noStrike" dirty="0">
+                <a:solidFill>
+                  <a:srgbClr val="000000"/>
+                </a:solidFill>
+                <a:latin typeface="Geist"/>
+                <a:ea typeface="Geist"/>
+                <a:cs typeface="Geist"/>
+                <a:sym typeface="Geist"/>
+              </a:rPr>
+              <a:t> (</a:t>
+            </a:r>
+            <a:r>
+              <a:rPr lang="en-US" sz="1700" b="0" i="0" u="none" strike="noStrike" dirty="0" err="1">
+                <a:solidFill>
+                  <a:srgbClr val="000000"/>
+                </a:solidFill>
+                <a:latin typeface="Geist"/>
+                <a:ea typeface="Geist"/>
+                <a:cs typeface="Geist"/>
+                <a:sym typeface="Geist"/>
+              </a:rPr>
+              <a:t>f.eks</a:t>
+            </a:r>
+            <a:r>
+              <a:rPr lang="en-US" sz="1700" b="0" i="0" u="none" strike="noStrike" dirty="0">
+                <a:solidFill>
+                  <a:srgbClr val="000000"/>
+                </a:solidFill>
+                <a:latin typeface="Geist"/>
+                <a:ea typeface="Geist"/>
+                <a:cs typeface="Geist"/>
+                <a:sym typeface="Geist"/>
+              </a:rPr>
+              <a:t>. at </a:t>
+            </a:r>
+            <a:r>
+              <a:rPr lang="en-US" sz="1700" b="0" i="0" u="none" strike="noStrike" dirty="0" err="1">
+                <a:solidFill>
+                  <a:srgbClr val="000000"/>
+                </a:solidFill>
+                <a:latin typeface="Geist"/>
+                <a:ea typeface="Geist"/>
+                <a:cs typeface="Geist"/>
+                <a:sym typeface="Geist"/>
+              </a:rPr>
+              <a:t>beregne</a:t>
+            </a:r>
+            <a:r>
+              <a:rPr lang="en-US" sz="1700" b="0" i="0" u="none" strike="noStrike" dirty="0">
+                <a:solidFill>
+                  <a:srgbClr val="000000"/>
+                </a:solidFill>
+                <a:latin typeface="Geist"/>
+                <a:ea typeface="Geist"/>
+                <a:cs typeface="Geist"/>
+                <a:sym typeface="Geist"/>
+              </a:rPr>
+              <a:t> </a:t>
+            </a:r>
+            <a:r>
+              <a:rPr lang="en-US" sz="1700" b="0" i="0" u="none" strike="noStrike" dirty="0" err="1">
+                <a:solidFill>
+                  <a:srgbClr val="000000"/>
+                </a:solidFill>
+                <a:latin typeface="Geist"/>
+                <a:ea typeface="Geist"/>
+                <a:cs typeface="Geist"/>
+                <a:sym typeface="Geist"/>
+              </a:rPr>
+              <a:t>gennemsnittet</a:t>
+            </a:r>
+            <a:r>
+              <a:rPr lang="en-US" sz="1700" b="0" i="0" u="none" strike="noStrike" dirty="0">
+                <a:solidFill>
+                  <a:srgbClr val="000000"/>
+                </a:solidFill>
+                <a:latin typeface="Geist"/>
+                <a:ea typeface="Geist"/>
+                <a:cs typeface="Geist"/>
+                <a:sym typeface="Geist"/>
+              </a:rPr>
+              <a:t> </a:t>
+            </a:r>
+            <a:r>
+              <a:rPr lang="en-US" sz="1700" b="0" i="0" u="none" strike="noStrike" dirty="0" err="1">
+                <a:solidFill>
+                  <a:srgbClr val="000000"/>
+                </a:solidFill>
+                <a:latin typeface="Geist"/>
+                <a:ea typeface="Geist"/>
+                <a:cs typeface="Geist"/>
+                <a:sym typeface="Geist"/>
+              </a:rPr>
+              <a:t>af</a:t>
+            </a:r>
+            <a:r>
+              <a:rPr lang="en-US" sz="1700" b="0" i="0" u="none" strike="noStrike" dirty="0">
+                <a:solidFill>
+                  <a:srgbClr val="000000"/>
+                </a:solidFill>
+                <a:latin typeface="Geist"/>
+                <a:ea typeface="Geist"/>
+                <a:cs typeface="Geist"/>
+                <a:sym typeface="Geist"/>
+              </a:rPr>
+              <a:t> </a:t>
+            </a:r>
+            <a:r>
+              <a:rPr lang="en-US" sz="1700" b="0" i="0" u="none" strike="noStrike" dirty="0" err="1">
+                <a:solidFill>
+                  <a:srgbClr val="000000"/>
+                </a:solidFill>
+                <a:latin typeface="Geist"/>
+                <a:ea typeface="Geist"/>
+                <a:cs typeface="Geist"/>
+                <a:sym typeface="Geist"/>
+              </a:rPr>
+              <a:t>tal</a:t>
+            </a:r>
+            <a:r>
+              <a:rPr lang="en-US" sz="1700" b="0" i="0" u="none" strike="noStrike" dirty="0">
+                <a:solidFill>
+                  <a:srgbClr val="000000"/>
+                </a:solidFill>
+                <a:latin typeface="Geist"/>
+                <a:ea typeface="Geist"/>
+                <a:cs typeface="Geist"/>
+                <a:sym typeface="Geist"/>
+              </a:rPr>
+              <a:t>).</a:t>
+            </a:r>
+            <a:endParaRPr dirty="0"/>
           </a:p>
         </p:txBody>
       </p:sp>

</xml_diff>